<commit_message>
Notebook auf Quarto umgestellt, Deck aufgeräumt
</commit_message>
<xml_diff>
--- a/Konsultation_IBI_Deck.pptx
+++ b/Konsultation_IBI_Deck.pptx
@@ -3248,7 +3248,7 @@
             </a:pPr>
             <a:r>
               <a:rPr/>
-              <a:t>2026-06-12</a:t>
+              <a:t>2026-06-13</a:t>
             </a:r>
           </a:p>
         </p:txBody>
@@ -3295,7 +3295,7 @@
             </a:pPr>
             <a:r>
               <a:rPr/>
-              <a:t>Transfer in die Bibliothekswelt</a:t>
+              <a:t>Der BookCrossing-Datensatz</a:t>
             </a:r>
           </a:p>
         </p:txBody>
@@ -3318,14 +3318,14 @@
             <a:pPr lvl="0"/>
             <a:r>
               <a:rPr/>
-              <a:t>Welche KI-Versprechen hören Bibliotheken aktuell von Anbietern?</a:t>
+              <a:t>2004 von Cai-Nicolas Ziegler aus der BookCrossing-Community gecrawlt</a:t>
             </a:r>
           </a:p>
           <a:p>
             <a:pPr lvl="0"/>
             <a:r>
               <a:rPr/>
-              <a:t>KI-gestützte Erschließung, Chatbots, Discovery</a:t>
+              <a:t>Demos in diesem Deck nutzen ein Teilsample (~494.000 Bewertungen):</a:t>
             </a:r>
           </a:p>
         </p:txBody>
@@ -3493,36 +3493,6 @@
             <p:ph type="title"/>
           </p:nvPr>
         </p:nvSpPr>
-        <p:spPr>
-          <a:xfrm>
-            <a:off x="457201" y="204787"/>
-            <a:ext cx="3008313" cy="871538"/>
-          </a:xfrm>
-        </p:spPr>
-        <p:txBody>
-          <a:bodyPr/>
-          <a:lstStyle/>
-          <a:p>
-            <a:pPr lvl="0" indent="0" marL="0">
-              <a:buNone/>
-            </a:pPr>
-            <a:r>
-              <a:rPr/>
-              <a:t>Der Book-Crossing-Datensatz</a:t>
-            </a:r>
-          </a:p>
-        </p:txBody>
-      </p:sp>
-      <p:sp>
-        <p:nvSpPr>
-          <p:cNvPr id="4" name="Text Placeholder 3"/>
-          <p:cNvSpPr>
-            <a:spLocks noGrp="1"/>
-          </p:cNvSpPr>
-          <p:nvPr>
-            <p:ph idx="2" sz="half" type="body"/>
-          </p:nvPr>
-        </p:nvSpPr>
         <p:spPr/>
         <p:txBody>
           <a:bodyPr/>
@@ -3533,7 +3503,7 @@
             </a:pPr>
             <a:r>
               <a:rPr/>
-              <a:t>2004 von Cai-Nicolas Ziegler aus der BookCrossing-Community gecrawlt — die Demos in diesem Deck nutzen ein Teilsample (~494.000 Bewertungen):</a:t>
+              <a:t>Der BookCrossing-Datensatz</a:t>
             </a:r>
           </a:p>
         </p:txBody>
@@ -3549,8 +3519,8 @@
           </p:nvPr>
         </p:nvGraphicFramePr>
         <p:xfrm>
-          <a:off x="3568700" y="203200"/>
-          <a:ext cx="5105400" cy="4381500"/>
+          <a:off x="457200" y="1193800"/>
+          <a:ext cx="8229600" cy="3390900"/>
         </p:xfrm>
         <a:graphic>
           <a:graphicData uri="http://schemas.openxmlformats.org/drawingml/2006/table">
@@ -3559,9 +3529,9 @@
                 <a:tableStyleId>{5C22544A-7EE6-4342-B048-85BDC9FD1C3A}</a:tableStyleId>
               </a:tblPr>
               <a:tblGrid>
-                <a:gridCol w="1320800"/>
-                <a:gridCol w="2476500"/>
-                <a:gridCol w="1320800"/>
+                <a:gridCol w="2171700"/>
+                <a:gridCol w="3886200"/>
+                <a:gridCol w="2171700"/>
               </a:tblGrid>
               <a:tr h="0">
                 <a:tc>
@@ -3800,230 +3770,43 @@
             </a:pPr>
             <a:r>
               <a:rPr/>
-              <a:t>Übung: Was stimmt mit diesen Daten nicht? (15 Min)</a:t>
+              <a:t>CRISP-DM</a:t>
             </a:r>
           </a:p>
         </p:txBody>
       </p:sp>
-      <p:sp>
-        <p:nvSpPr>
-          <p:cNvPr id="3" name="Content Placeholder 2"/>
-          <p:cNvSpPr>
-            <a:spLocks noGrp="1"/>
-          </p:cNvSpPr>
-          <p:nvPr>
-            <p:ph idx="1"/>
-          </p:nvPr>
-        </p:nvSpPr>
-        <p:spPr/>
-        <p:txBody>
-          <a:bodyPr/>
-          <a:lstStyle/>
-          <a:p>
-            <a:pPr lvl="0"/>
-            <a:r>
-              <a:rPr/>
-              <a:t>Gruppe 1: BX-Users</a:t>
-            </a:r>
-          </a:p>
-          <a:p>
-            <a:pPr lvl="0"/>
-            <a:r>
-              <a:rPr/>
-              <a:t>Gruppe 2: BX-Books</a:t>
-            </a:r>
-          </a:p>
-          <a:p>
-            <a:pPr lvl="0"/>
-            <a:r>
-              <a:rPr/>
-              <a:t>Gruppe 3: BX-Book-Ratings</a:t>
-            </a:r>
-          </a:p>
-        </p:txBody>
-      </p:sp>
+      <p:pic>
+        <p:nvPicPr>
+          <p:cNvPr descr="images/CRISP-DM_Process_Diagram.png" id="0" name="Picture 1"/>
+          <p:cNvPicPr>
+            <a:picLocks noGrp="1" noChangeAspect="1"/>
+          </p:cNvPicPr>
+          <p:nvPr/>
+        </p:nvPicPr>
+        <p:blipFill>
+          <a:blip r:embed="rId2"/>
+          <a:stretch>
+            <a:fillRect/>
+          </a:stretch>
+        </p:blipFill>
+        <p:spPr bwMode="auto">
+          <a:xfrm>
+            <a:off x="2882900" y="1193800"/>
+            <a:ext cx="3378200" cy="3390900"/>
+          </a:xfrm>
+          <a:prstGeom prst="rect">
+            <a:avLst/>
+          </a:prstGeom>
+          <a:noFill/>
+          <a:ln w="9525">
+            <a:noFill/>
+            <a:headEnd/>
+            <a:tailEnd/>
+          </a:ln>
+        </p:spPr>
+      </p:pic>
     </p:spTree>
   </p:cSld>
-  <p:timing>
-    <p:tnLst>
-      <p:par>
-        <p:cTn id="1" dur="indefinite" restart="never" nodeType="tmRoot">
-          <p:childTnLst>
-            <p:seq concurrent="1" nextAc="seek">
-              <p:cTn id="2" dur="indefinite" nodeType="mainSeq">
-                <p:childTnLst>
-                  <p:par>
-                    <p:cTn id="3" fill="hold">
-                      <p:stCondLst>
-                        <p:cond delay="indefinite"/>
-                      </p:stCondLst>
-                      <p:childTnLst>
-                        <p:par>
-                          <p:cTn id="4" fill="hold">
-                            <p:stCondLst>
-                              <p:cond delay="0"/>
-                            </p:stCondLst>
-                            <p:childTnLst>
-                              <p:par>
-                                <p:cTn id="5" presetID="1" presetClass="entr" presetSubtype="0" fill="hold" grpId="0" nodeType="clickEffect">
-                                  <p:stCondLst>
-                                    <p:cond delay="0"/>
-                                  </p:stCondLst>
-                                  <p:childTnLst>
-                                    <p:set>
-                                      <p:cBhvr>
-                                        <p:cTn id="6" dur="1" fill="hold">
-                                          <p:stCondLst>
-                                            <p:cond delay="0"/>
-                                          </p:stCondLst>
-                                        </p:cTn>
-                                        <p:tgtEl>
-                                          <p:spTgt spid="3">
-                                            <p:txEl>
-                                              <p:pRg st="0" end="0"/>
-                                            </p:txEl>
-                                          </p:spTgt>
-                                        </p:tgtEl>
-                                        <p:attrNameLst>
-                                          <p:attrName>style.visibility</p:attrName>
-                                        </p:attrNameLst>
-                                      </p:cBhvr>
-                                      <p:to>
-                                        <p:strVal val="visible"/>
-                                      </p:to>
-                                    </p:set>
-                                  </p:childTnLst>
-                                </p:cTn>
-                              </p:par>
-                            </p:childTnLst>
-                          </p:cTn>
-                        </p:par>
-                      </p:childTnLst>
-                    </p:cTn>
-                  </p:par>
-                  <p:par>
-                    <p:cTn id="7" fill="hold">
-                      <p:stCondLst>
-                        <p:cond delay="indefinite"/>
-                      </p:stCondLst>
-                      <p:childTnLst>
-                        <p:par>
-                          <p:cTn id="8" fill="hold">
-                            <p:stCondLst>
-                              <p:cond delay="0"/>
-                            </p:stCondLst>
-                            <p:childTnLst>
-                              <p:par>
-                                <p:cTn id="9" presetID="1" presetClass="entr" presetSubtype="0" fill="hold" grpId="0" nodeType="clickEffect">
-                                  <p:stCondLst>
-                                    <p:cond delay="0"/>
-                                  </p:stCondLst>
-                                  <p:childTnLst>
-                                    <p:set>
-                                      <p:cBhvr>
-                                        <p:cTn id="10" dur="1" fill="hold">
-                                          <p:stCondLst>
-                                            <p:cond delay="0"/>
-                                          </p:stCondLst>
-                                        </p:cTn>
-                                        <p:tgtEl>
-                                          <p:spTgt spid="3">
-                                            <p:txEl>
-                                              <p:pRg st="1" end="1"/>
-                                            </p:txEl>
-                                          </p:spTgt>
-                                        </p:tgtEl>
-                                        <p:attrNameLst>
-                                          <p:attrName>style.visibility</p:attrName>
-                                        </p:attrNameLst>
-                                      </p:cBhvr>
-                                      <p:to>
-                                        <p:strVal val="visible"/>
-                                      </p:to>
-                                    </p:set>
-                                  </p:childTnLst>
-                                </p:cTn>
-                              </p:par>
-                            </p:childTnLst>
-                          </p:cTn>
-                        </p:par>
-                      </p:childTnLst>
-                    </p:cTn>
-                  </p:par>
-                  <p:par>
-                    <p:cTn id="11" fill="hold">
-                      <p:stCondLst>
-                        <p:cond delay="indefinite"/>
-                      </p:stCondLst>
-                      <p:childTnLst>
-                        <p:par>
-                          <p:cTn id="12" fill="hold">
-                            <p:stCondLst>
-                              <p:cond delay="0"/>
-                            </p:stCondLst>
-                            <p:childTnLst>
-                              <p:par>
-                                <p:cTn id="13" presetID="1" presetClass="entr" presetSubtype="0" fill="hold" grpId="0" nodeType="clickEffect">
-                                  <p:stCondLst>
-                                    <p:cond delay="0"/>
-                                  </p:stCondLst>
-                                  <p:childTnLst>
-                                    <p:set>
-                                      <p:cBhvr>
-                                        <p:cTn id="14" dur="1" fill="hold">
-                                          <p:stCondLst>
-                                            <p:cond delay="0"/>
-                                          </p:stCondLst>
-                                        </p:cTn>
-                                        <p:tgtEl>
-                                          <p:spTgt spid="3">
-                                            <p:txEl>
-                                              <p:pRg st="2" end="2"/>
-                                            </p:txEl>
-                                          </p:spTgt>
-                                        </p:tgtEl>
-                                        <p:attrNameLst>
-                                          <p:attrName>style.visibility</p:attrName>
-                                        </p:attrNameLst>
-                                      </p:cBhvr>
-                                      <p:to>
-                                        <p:strVal val="visible"/>
-                                      </p:to>
-                                    </p:set>
-                                  </p:childTnLst>
-                                </p:cTn>
-                              </p:par>
-                            </p:childTnLst>
-                          </p:cTn>
-                        </p:par>
-                      </p:childTnLst>
-                    </p:cTn>
-                  </p:par>
-                </p:childTnLst>
-              </p:cTn>
-              <p:prevCondLst>
-                <p:cond evt="onPrev" delay="0">
-                  <p:tgtEl>
-                    <p:sldTgt/>
-                  </p:tgtEl>
-                </p:cond>
-              </p:prevCondLst>
-              <p:nextCondLst>
-                <p:cond evt="onNext" delay="0">
-                  <p:tgtEl>
-                    <p:sldTgt/>
-                  </p:tgtEl>
-                </p:cond>
-              </p:nextCondLst>
-            </p:seq>
-          </p:childTnLst>
-        </p:cTn>
-      </p:par>
-    </p:tnLst>
-    <p:bldLst>
-      <p:bldP spid="3" grpId="0" uiExpand="1" build="p"/>
-    </p:bldLst>
-  </p:timing>
 </p:sld>
 </file>
 
@@ -4064,7 +3847,7 @@
             </a:pPr>
             <a:r>
               <a:rPr/>
-              <a:t>Auflösung: die üblichen Verdächtigen</a:t>
+              <a:t>Was stimmt mit diesen Daten nicht?</a:t>
             </a:r>
           </a:p>
         </p:txBody>
@@ -4091,7 +3874,7 @@
             </a:r>
             <a:r>
               <a:rPr/>
-              <a:t> 0 ist kein Verriss, sondern </a:t>
+              <a:t> 0 ist kein Bewertung, sondern </a:t>
             </a:r>
             <a:r>
               <a:rPr b="1"/>
@@ -4099,7 +3882,7 @@
             </a:r>
             <a:r>
               <a:rPr/>
-              <a:t> — über die Hälfte aller Einträge!</a:t>
+              <a:t>.</a:t>
             </a:r>
           </a:p>
           <a:p>
@@ -4121,7 +3904,7 @@
             </a:r>
             <a:r>
               <a:rPr/>
-              <a:t> mehrere ISBNs pro Werk (Auflagen!), Erscheinungsjahre 0 und 2050</a:t>
+              <a:t> mehrere ISBNs pro Werk (Auflagen), Erscheinungsjahre 0 und 2050</a:t>
             </a:r>
           </a:p>
           <a:p>
@@ -4468,7 +4251,7 @@
             </a:pPr>
             <a:r>
               <a:rPr/>
-              <a:t>Ein Diagramm entlarvt die Daten</a:t>
+              <a:t>Visualisierung als erster Schritt in der Datenanalyse</a:t>
             </a:r>
           </a:p>
         </p:txBody>
@@ -4527,6 +4310,31 @@
       </p:grpSpPr>
       <p:sp>
         <p:nvSpPr>
+          <p:cNvPr id="2" name="Title 1"/>
+          <p:cNvSpPr>
+            <a:spLocks noGrp="1"/>
+          </p:cNvSpPr>
+          <p:nvPr>
+            <p:ph type="title"/>
+          </p:nvPr>
+        </p:nvSpPr>
+        <p:spPr/>
+        <p:txBody>
+          <a:bodyPr/>
+          <a:lstStyle/>
+          <a:p>
+            <a:pPr lvl="0" indent="0" marL="0">
+              <a:buNone/>
+            </a:pPr>
+            <a:r>
+              <a:rPr/>
+              <a:t>Exkurs: Was heißt Sparsity?</a:t>
+            </a:r>
+          </a:p>
+        </p:txBody>
+      </p:sp>
+      <p:sp>
+        <p:nvSpPr>
           <p:cNvPr id="3" name="Content Placeholder 2"/>
           <p:cNvSpPr>
             <a:spLocks noGrp="1"/>
@@ -4543,7 +4351,40 @@
             <a:pPr lvl="0"/>
             <a:r>
               <a:rPr/>
-              <a:t>Altersangaben von 0 bis 244 — beim Alter wird gelogen (oder getippt)</a:t>
+              <a:t>Die Tabelle ist fast leer.</a:t>
+            </a:r>
+          </a:p>
+          <a:p>
+            <a:pPr lvl="0"/>
+            <a:r>
+              <a:rPr/>
+              <a:t>Beispiel: eine Tabelle mit einer Zeile pro Nutzer:in und einer Spalte pro Buch, in den Zellen die Bewertungen</a:t>
+            </a:r>
+          </a:p>
+          <a:p>
+            <a:pPr lvl="0"/>
+            <a:r>
+              <a:rPr/>
+              <a:t>278.000 × 271.000 ≈ </a:t>
+            </a:r>
+            <a:r>
+              <a:rPr b="1"/>
+              <a:t>75 Milliarden Zellen</a:t>
+            </a:r>
+            <a:r>
+              <a:rPr/>
+              <a:t> — gefüllt sind ~1 Mio., also </a:t>
+            </a:r>
+            <a:r>
+              <a:rPr b="1"/>
+              <a:t>0,002 %</a:t>
+            </a:r>
+          </a:p>
+          <a:p>
+            <a:pPr lvl="0"/>
+            <a:r>
+              <a:rPr/>
+              <a:t>Selbst die eifrigste Viel-Leserin füllt ihre Zeile zu weniger als 0,1 %</a:t>
             </a:r>
           </a:p>
         </p:txBody>
@@ -4587,6 +4428,153 @@
                                           <p:spTgt spid="3">
                                             <p:txEl>
                                               <p:pRg st="0" end="0"/>
+                                            </p:txEl>
+                                          </p:spTgt>
+                                        </p:tgtEl>
+                                        <p:attrNameLst>
+                                          <p:attrName>style.visibility</p:attrName>
+                                        </p:attrNameLst>
+                                      </p:cBhvr>
+                                      <p:to>
+                                        <p:strVal val="visible"/>
+                                      </p:to>
+                                    </p:set>
+                                  </p:childTnLst>
+                                </p:cTn>
+                              </p:par>
+                            </p:childTnLst>
+                          </p:cTn>
+                        </p:par>
+                      </p:childTnLst>
+                    </p:cTn>
+                  </p:par>
+                  <p:par>
+                    <p:cTn id="7" fill="hold">
+                      <p:stCondLst>
+                        <p:cond delay="indefinite"/>
+                      </p:stCondLst>
+                      <p:childTnLst>
+                        <p:par>
+                          <p:cTn id="8" fill="hold">
+                            <p:stCondLst>
+                              <p:cond delay="0"/>
+                            </p:stCondLst>
+                            <p:childTnLst>
+                              <p:par>
+                                <p:cTn id="9" presetID="1" presetClass="entr" presetSubtype="0" fill="hold" grpId="0" nodeType="clickEffect">
+                                  <p:stCondLst>
+                                    <p:cond delay="0"/>
+                                  </p:stCondLst>
+                                  <p:childTnLst>
+                                    <p:set>
+                                      <p:cBhvr>
+                                        <p:cTn id="10" dur="1" fill="hold">
+                                          <p:stCondLst>
+                                            <p:cond delay="0"/>
+                                          </p:stCondLst>
+                                        </p:cTn>
+                                        <p:tgtEl>
+                                          <p:spTgt spid="3">
+                                            <p:txEl>
+                                              <p:pRg st="1" end="1"/>
+                                            </p:txEl>
+                                          </p:spTgt>
+                                        </p:tgtEl>
+                                        <p:attrNameLst>
+                                          <p:attrName>style.visibility</p:attrName>
+                                        </p:attrNameLst>
+                                      </p:cBhvr>
+                                      <p:to>
+                                        <p:strVal val="visible"/>
+                                      </p:to>
+                                    </p:set>
+                                  </p:childTnLst>
+                                </p:cTn>
+                              </p:par>
+                            </p:childTnLst>
+                          </p:cTn>
+                        </p:par>
+                      </p:childTnLst>
+                    </p:cTn>
+                  </p:par>
+                  <p:par>
+                    <p:cTn id="11" fill="hold">
+                      <p:stCondLst>
+                        <p:cond delay="indefinite"/>
+                      </p:stCondLst>
+                      <p:childTnLst>
+                        <p:par>
+                          <p:cTn id="12" fill="hold">
+                            <p:stCondLst>
+                              <p:cond delay="0"/>
+                            </p:stCondLst>
+                            <p:childTnLst>
+                              <p:par>
+                                <p:cTn id="13" presetID="1" presetClass="entr" presetSubtype="0" fill="hold" grpId="0" nodeType="clickEffect">
+                                  <p:stCondLst>
+                                    <p:cond delay="0"/>
+                                  </p:stCondLst>
+                                  <p:childTnLst>
+                                    <p:set>
+                                      <p:cBhvr>
+                                        <p:cTn id="14" dur="1" fill="hold">
+                                          <p:stCondLst>
+                                            <p:cond delay="0"/>
+                                          </p:stCondLst>
+                                        </p:cTn>
+                                        <p:tgtEl>
+                                          <p:spTgt spid="3">
+                                            <p:txEl>
+                                              <p:pRg st="2" end="2"/>
+                                            </p:txEl>
+                                          </p:spTgt>
+                                        </p:tgtEl>
+                                        <p:attrNameLst>
+                                          <p:attrName>style.visibility</p:attrName>
+                                        </p:attrNameLst>
+                                      </p:cBhvr>
+                                      <p:to>
+                                        <p:strVal val="visible"/>
+                                      </p:to>
+                                    </p:set>
+                                  </p:childTnLst>
+                                </p:cTn>
+                              </p:par>
+                            </p:childTnLst>
+                          </p:cTn>
+                        </p:par>
+                      </p:childTnLst>
+                    </p:cTn>
+                  </p:par>
+                  <p:par>
+                    <p:cTn id="15" fill="hold">
+                      <p:stCondLst>
+                        <p:cond delay="indefinite"/>
+                      </p:stCondLst>
+                      <p:childTnLst>
+                        <p:par>
+                          <p:cTn id="16" fill="hold">
+                            <p:stCondLst>
+                              <p:cond delay="0"/>
+                            </p:stCondLst>
+                            <p:childTnLst>
+                              <p:par>
+                                <p:cTn id="17" presetID="1" presetClass="entr" presetSubtype="0" fill="hold" grpId="0" nodeType="clickEffect">
+                                  <p:stCondLst>
+                                    <p:cond delay="0"/>
+                                  </p:stCondLst>
+                                  <p:childTnLst>
+                                    <p:set>
+                                      <p:cBhvr>
+                                        <p:cTn id="18" dur="1" fill="hold">
+                                          <p:stCondLst>
+                                            <p:cond delay="0"/>
+                                          </p:stCondLst>
+                                        </p:cTn>
+                                        <p:tgtEl>
+                                          <p:spTgt spid="3">
+                                            <p:txEl>
+                                              <p:pRg st="3" end="3"/>
                                             </p:txEl>
                                           </p:spTgt>
                                         </p:tgtEl>
@@ -4672,7 +4660,7 @@
             </a:pPr>
             <a:r>
               <a:rPr/>
-              <a:t>Exkurs: Was heißt Sparsity?</a:t>
+              <a:t>Sparsity: die Folgen</a:t>
             </a:r>
           </a:p>
         </p:txBody>
@@ -4695,33 +4683,29 @@
             <a:pPr lvl="0"/>
             <a:r>
               <a:rPr/>
-              <a:t>Denkbild: eine Tabelle mit einer Zeile pro Nutzer:in und einer Spalte pro Buch, in den Zellen die Bewertungen</a:t>
+              <a:t>Selbst populäre Buchpaare tauchen nur in einem Promille der Körbe auf — Schwellenwerte müssen winzig sein</a:t>
             </a:r>
           </a:p>
           <a:p>
             <a:pPr lvl="0"/>
             <a:r>
               <a:rPr/>
-              <a:t>278.000 × 271.000 ≈ </a:t>
+              <a:t>Zwei beliebige Nutzer:innen haben oft </a:t>
             </a:r>
             <a:r>
               <a:rPr b="1"/>
-              <a:t>75 Milliarden Zellen</a:t>
-            </a:r>
-            <a:r>
-              <a:rPr/>
-              <a:t> — gefüllt sind ~1 Mio., also </a:t>
-            </a:r>
-            <a:r>
-              <a:rPr b="1"/>
-              <a:t>0,002 %</a:t>
+              <a:t>kein einziges</a:t>
+            </a:r>
+            <a:r>
+              <a:rPr/>
+              <a:t> gemeinsames Buch — Ähnlichkeit lässt sich gar nicht berechnen</a:t>
             </a:r>
           </a:p>
           <a:p>
             <a:pPr lvl="0"/>
             <a:r>
               <a:rPr/>
-              <a:t>Selbst die eifrigste Viel-Leserin füllt ihre Zeile zu weniger als 0,1 %</a:t>
+              <a:t>Muster entstehen erst, weil sich Millionen fast leerer Zeilen überlagern</a:t>
             </a:r>
           </a:p>
         </p:txBody>
@@ -4948,7 +4932,7 @@
             </a:pPr>
             <a:r>
               <a:rPr/>
-              <a:t>Sparsity: die Folgen</a:t>
+              <a:t>FRBR und Sparsity</a:t>
             </a:r>
           </a:p>
         </p:txBody>
@@ -4971,307 +4955,36 @@
             <a:pPr lvl="0"/>
             <a:r>
               <a:rPr/>
-              <a:t>Selbst populäre Buchpaare tauchen nur in einem Promille der Körbe auf — Schwellenwerte müssen winzig sein</a:t>
+              <a:t>Sparsity entsteht, weil Nutzer:innen zu wenige Bücher bewertet haben.</a:t>
             </a:r>
           </a:p>
           <a:p>
             <a:pPr lvl="0"/>
             <a:r>
               <a:rPr/>
-              <a:t>Zwei beliebige Nutzer:innen haben oft </a:t>
+              <a:t>FRBR: dasselbe Werk taucht unter vielen ISBNs auf: Sparsity wird verschärft, weil wenige Bewertungen für ein Werk auf mehrere ISBNs verteilt werden</a:t>
+            </a:r>
+          </a:p>
+          <a:p>
+            <a:pPr lvl="0"/>
+            <a:r>
+              <a:rPr/>
+              <a:t>BookCrossing kennt </a:t>
             </a:r>
             <a:r>
               <a:rPr b="1"/>
-              <a:t>kein einziges</a:t>
-            </a:r>
-            <a:r>
-              <a:rPr/>
-              <a:t> gemeinsames Buch — Ähnlichkeit lässt sich gar nicht berechnen</a:t>
+              <a:t>nur ISBNs = Manifestationen</a:t>
+            </a:r>
+            <a:r>
+              <a:rPr/>
+              <a:t> — das Werk müssen wir per Data Mining rekonstruieren</a:t>
             </a:r>
           </a:p>
           <a:p>
             <a:pPr lvl="0"/>
             <a:r>
               <a:rPr/>
-              <a:t>Muster entstehen erst, weil sich Millionen fast leerer Zeilen überlagern</a:t>
-            </a:r>
-          </a:p>
-        </p:txBody>
-      </p:sp>
-    </p:spTree>
-  </p:cSld>
-  <p:timing>
-    <p:tnLst>
-      <p:par>
-        <p:cTn id="1" dur="indefinite" restart="never" nodeType="tmRoot">
-          <p:childTnLst>
-            <p:seq concurrent="1" nextAc="seek">
-              <p:cTn id="2" dur="indefinite" nodeType="mainSeq">
-                <p:childTnLst>
-                  <p:par>
-                    <p:cTn id="3" fill="hold">
-                      <p:stCondLst>
-                        <p:cond delay="indefinite"/>
-                      </p:stCondLst>
-                      <p:childTnLst>
-                        <p:par>
-                          <p:cTn id="4" fill="hold">
-                            <p:stCondLst>
-                              <p:cond delay="0"/>
-                            </p:stCondLst>
-                            <p:childTnLst>
-                              <p:par>
-                                <p:cTn id="5" presetID="1" presetClass="entr" presetSubtype="0" fill="hold" grpId="0" nodeType="clickEffect">
-                                  <p:stCondLst>
-                                    <p:cond delay="0"/>
-                                  </p:stCondLst>
-                                  <p:childTnLst>
-                                    <p:set>
-                                      <p:cBhvr>
-                                        <p:cTn id="6" dur="1" fill="hold">
-                                          <p:stCondLst>
-                                            <p:cond delay="0"/>
-                                          </p:stCondLst>
-                                        </p:cTn>
-                                        <p:tgtEl>
-                                          <p:spTgt spid="3">
-                                            <p:txEl>
-                                              <p:pRg st="0" end="0"/>
-                                            </p:txEl>
-                                          </p:spTgt>
-                                        </p:tgtEl>
-                                        <p:attrNameLst>
-                                          <p:attrName>style.visibility</p:attrName>
-                                        </p:attrNameLst>
-                                      </p:cBhvr>
-                                      <p:to>
-                                        <p:strVal val="visible"/>
-                                      </p:to>
-                                    </p:set>
-                                  </p:childTnLst>
-                                </p:cTn>
-                              </p:par>
-                            </p:childTnLst>
-                          </p:cTn>
-                        </p:par>
-                      </p:childTnLst>
-                    </p:cTn>
-                  </p:par>
-                  <p:par>
-                    <p:cTn id="7" fill="hold">
-                      <p:stCondLst>
-                        <p:cond delay="indefinite"/>
-                      </p:stCondLst>
-                      <p:childTnLst>
-                        <p:par>
-                          <p:cTn id="8" fill="hold">
-                            <p:stCondLst>
-                              <p:cond delay="0"/>
-                            </p:stCondLst>
-                            <p:childTnLst>
-                              <p:par>
-                                <p:cTn id="9" presetID="1" presetClass="entr" presetSubtype="0" fill="hold" grpId="0" nodeType="clickEffect">
-                                  <p:stCondLst>
-                                    <p:cond delay="0"/>
-                                  </p:stCondLst>
-                                  <p:childTnLst>
-                                    <p:set>
-                                      <p:cBhvr>
-                                        <p:cTn id="10" dur="1" fill="hold">
-                                          <p:stCondLst>
-                                            <p:cond delay="0"/>
-                                          </p:stCondLst>
-                                        </p:cTn>
-                                        <p:tgtEl>
-                                          <p:spTgt spid="3">
-                                            <p:txEl>
-                                              <p:pRg st="1" end="1"/>
-                                            </p:txEl>
-                                          </p:spTgt>
-                                        </p:tgtEl>
-                                        <p:attrNameLst>
-                                          <p:attrName>style.visibility</p:attrName>
-                                        </p:attrNameLst>
-                                      </p:cBhvr>
-                                      <p:to>
-                                        <p:strVal val="visible"/>
-                                      </p:to>
-                                    </p:set>
-                                  </p:childTnLst>
-                                </p:cTn>
-                              </p:par>
-                            </p:childTnLst>
-                          </p:cTn>
-                        </p:par>
-                      </p:childTnLst>
-                    </p:cTn>
-                  </p:par>
-                  <p:par>
-                    <p:cTn id="11" fill="hold">
-                      <p:stCondLst>
-                        <p:cond delay="indefinite"/>
-                      </p:stCondLst>
-                      <p:childTnLst>
-                        <p:par>
-                          <p:cTn id="12" fill="hold">
-                            <p:stCondLst>
-                              <p:cond delay="0"/>
-                            </p:stCondLst>
-                            <p:childTnLst>
-                              <p:par>
-                                <p:cTn id="13" presetID="1" presetClass="entr" presetSubtype="0" fill="hold" grpId="0" nodeType="clickEffect">
-                                  <p:stCondLst>
-                                    <p:cond delay="0"/>
-                                  </p:stCondLst>
-                                  <p:childTnLst>
-                                    <p:set>
-                                      <p:cBhvr>
-                                        <p:cTn id="14" dur="1" fill="hold">
-                                          <p:stCondLst>
-                                            <p:cond delay="0"/>
-                                          </p:stCondLst>
-                                        </p:cTn>
-                                        <p:tgtEl>
-                                          <p:spTgt spid="3">
-                                            <p:txEl>
-                                              <p:pRg st="2" end="2"/>
-                                            </p:txEl>
-                                          </p:spTgt>
-                                        </p:tgtEl>
-                                        <p:attrNameLst>
-                                          <p:attrName>style.visibility</p:attrName>
-                                        </p:attrNameLst>
-                                      </p:cBhvr>
-                                      <p:to>
-                                        <p:strVal val="visible"/>
-                                      </p:to>
-                                    </p:set>
-                                  </p:childTnLst>
-                                </p:cTn>
-                              </p:par>
-                            </p:childTnLst>
-                          </p:cTn>
-                        </p:par>
-                      </p:childTnLst>
-                    </p:cTn>
-                  </p:par>
-                </p:childTnLst>
-              </p:cTn>
-              <p:prevCondLst>
-                <p:cond evt="onPrev" delay="0">
-                  <p:tgtEl>
-                    <p:sldTgt/>
-                  </p:tgtEl>
-                </p:cond>
-              </p:prevCondLst>
-              <p:nextCondLst>
-                <p:cond evt="onNext" delay="0">
-                  <p:tgtEl>
-                    <p:sldTgt/>
-                  </p:tgtEl>
-                </p:cond>
-              </p:nextCondLst>
-            </p:seq>
-          </p:childTnLst>
-        </p:cTn>
-      </p:par>
-    </p:tnLst>
-    <p:bldLst>
-      <p:bldP spid="3" grpId="0" uiExpand="1" build="p"/>
-    </p:bldLst>
-  </p:timing>
-</p:sld>
-</file>
-
-<file path=ppt/slides/slide18.xml><?xml version="1.0" encoding="utf-8"?>
-<p:sld xmlns:a="http://schemas.openxmlformats.org/drawingml/2006/main" xmlns:r="http://schemas.openxmlformats.org/officeDocument/2006/relationships" xmlns:p="http://schemas.openxmlformats.org/presentationml/2006/main">
-  <p:cSld>
-    <p:spTree>
-      <p:nvGrpSpPr>
-        <p:cNvPr id="1" name=""/>
-        <p:cNvGrpSpPr/>
-        <p:nvPr/>
-      </p:nvGrpSpPr>
-      <p:grpSpPr>
-        <a:xfrm>
-          <a:off x="0" y="0"/>
-          <a:ext cx="0" cy="0"/>
-          <a:chOff x="0" y="0"/>
-          <a:chExt cx="0" cy="0"/>
-        </a:xfrm>
-      </p:grpSpPr>
-      <p:sp>
-        <p:nvSpPr>
-          <p:cNvPr id="2" name="Title 1"/>
-          <p:cNvSpPr>
-            <a:spLocks noGrp="1"/>
-          </p:cNvSpPr>
-          <p:nvPr>
-            <p:ph type="title"/>
-          </p:nvPr>
-        </p:nvSpPr>
-        <p:spPr/>
-        <p:txBody>
-          <a:bodyPr/>
-          <a:lstStyle/>
-          <a:p>
-            <a:pPr lvl="0" indent="0" marL="0">
-              <a:buNone/>
-            </a:pPr>
-            <a:r>
-              <a:rPr/>
-              <a:t>Kommt Ihnen das bekannt vor?</a:t>
-            </a:r>
-          </a:p>
-        </p:txBody>
-      </p:sp>
-      <p:sp>
-        <p:nvSpPr>
-          <p:cNvPr id="3" name="Content Placeholder 2"/>
-          <p:cNvSpPr>
-            <a:spLocks noGrp="1"/>
-          </p:cNvSpPr>
-          <p:nvPr>
-            <p:ph idx="1"/>
-          </p:nvPr>
-        </p:nvSpPr>
-        <p:spPr/>
-        <p:txBody>
-          <a:bodyPr/>
-          <a:lstStyle/>
-          <a:p>
-            <a:pPr lvl="0"/>
-            <a:r>
-              <a:rPr/>
-              <a:t>Werk vs. Manifestation → FRBR</a:t>
-            </a:r>
-          </a:p>
-          <a:p>
-            <a:pPr lvl="0"/>
-            <a:r>
-              <a:rPr/>
-              <a:t>Uneinheitliche Namen → Normdaten</a:t>
-            </a:r>
-          </a:p>
-          <a:p>
-            <a:pPr lvl="0"/>
-            <a:r>
-              <a:rPr/>
-              <a:t>Mehrfache ISBNs → Dublettenkontrolle</a:t>
-            </a:r>
-          </a:p>
-          <a:p>
-            <a:pPr lvl="0"/>
-            <a:r>
-              <a:rPr b="1"/>
-              <a:t>Bibliothekar:innen haben hier Fachkompetenz, die Data-Science-Teams fehlt</a:t>
-            </a:r>
-          </a:p>
-          <a:p>
-            <a:pPr lvl="0"/>
-            <a:r>
-              <a:rPr/>
-              <a:t>→ Rolle: Subject Matter Expert</a:t>
+              <a:t>Genau das macht Record Linkage (später)</a:t>
             </a:r>
           </a:p>
         </p:txBody>
@@ -5482,55 +5195,6 @@
                       </p:childTnLst>
                     </p:cTn>
                   </p:par>
-                  <p:par>
-                    <p:cTn id="19" fill="hold">
-                      <p:stCondLst>
-                        <p:cond delay="indefinite"/>
-                      </p:stCondLst>
-                      <p:childTnLst>
-                        <p:par>
-                          <p:cTn id="20" fill="hold">
-                            <p:stCondLst>
-                              <p:cond delay="0"/>
-                            </p:stCondLst>
-                            <p:childTnLst>
-                              <p:par>
-                                <p:cTn id="21" presetID="1" presetClass="entr" presetSubtype="0" fill="hold" grpId="0" nodeType="clickEffect">
-                                  <p:stCondLst>
-                                    <p:cond delay="0"/>
-                                  </p:stCondLst>
-                                  <p:childTnLst>
-                                    <p:set>
-                                      <p:cBhvr>
-                                        <p:cTn id="22" dur="1" fill="hold">
-                                          <p:stCondLst>
-                                            <p:cond delay="0"/>
-                                          </p:stCondLst>
-                                        </p:cTn>
-                                        <p:tgtEl>
-                                          <p:spTgt spid="3">
-                                            <p:txEl>
-                                              <p:pRg st="4" end="4"/>
-                                            </p:txEl>
-                                          </p:spTgt>
-                                        </p:tgtEl>
-                                        <p:attrNameLst>
-                                          <p:attrName>style.visibility</p:attrName>
-                                        </p:attrNameLst>
-                                      </p:cBhvr>
-                                      <p:to>
-                                        <p:strVal val="visible"/>
-                                      </p:to>
-                                    </p:set>
-                                  </p:childTnLst>
-                                </p:cTn>
-                              </p:par>
-                            </p:childTnLst>
-                          </p:cTn>
-                        </p:par>
-                      </p:childTnLst>
-                    </p:cTn>
-                  </p:par>
                 </p:childTnLst>
               </p:cTn>
               <p:prevCondLst>
@@ -5556,6 +5220,58 @@
       <p:bldP spid="3" grpId="0" uiExpand="1" build="p"/>
     </p:bldLst>
   </p:timing>
+</p:sld>
+</file>
+
+<file path=ppt/slides/slide18.xml><?xml version="1.0" encoding="utf-8"?>
+<p:sld xmlns:a="http://schemas.openxmlformats.org/drawingml/2006/main" xmlns:r="http://schemas.openxmlformats.org/officeDocument/2006/relationships" xmlns:p="http://schemas.openxmlformats.org/presentationml/2006/main">
+  <p:cSld>
+    <p:spTree>
+      <p:nvGrpSpPr>
+        <p:cNvPr id="1" name=""/>
+        <p:cNvGrpSpPr/>
+        <p:nvPr/>
+      </p:nvGrpSpPr>
+      <p:grpSpPr>
+        <a:xfrm>
+          <a:off x="0" y="0"/>
+          <a:ext cx="0" cy="0"/>
+          <a:chOff x="0" y="0"/>
+          <a:chExt cx="0" cy="0"/>
+        </a:xfrm>
+      </p:grpSpPr>
+      <p:sp>
+        <p:nvSpPr>
+          <p:cNvPr id="2" name="Title 1"/>
+          <p:cNvSpPr>
+            <a:spLocks noGrp="1"/>
+          </p:cNvSpPr>
+          <p:nvPr>
+            <p:ph type="title"/>
+          </p:nvPr>
+        </p:nvSpPr>
+        <p:spPr>
+          <a:xfrm>
+            <a:off x="722313" y="3305176"/>
+            <a:ext cx="7772400" cy="1021556"/>
+          </a:xfrm>
+        </p:spPr>
+        <p:txBody>
+          <a:bodyPr/>
+          <a:lstStyle/>
+          <a:p>
+            <a:pPr lvl="0" indent="0" marL="0">
+              <a:buNone/>
+            </a:pPr>
+            <a:r>
+              <a:rPr/>
+              <a:t>Data Mining-Ansätze für den BookCrossing-Datensatz</a:t>
+            </a:r>
+          </a:p>
+        </p:txBody>
+      </p:sp>
+    </p:spTree>
+  </p:cSld>
 </p:sld>
 </file>
 
@@ -5596,7 +5312,7 @@
             </a:pPr>
             <a:r>
               <a:rPr/>
-              <a:t>Zur Erinnerung: FRBR (Sie kennen das besser als ich)</a:t>
+              <a:t>Software</a:t>
             </a:r>
           </a:p>
         </p:txBody>
@@ -5619,48 +5335,28 @@
             <a:pPr lvl="0"/>
             <a:r>
               <a:rPr/>
-              <a:t>IFLA-Referenzmodell (1998, heute Teil des IFLA LRM): </a:t>
-            </a:r>
-            <a:r>
-              <a:rPr b="1"/>
-              <a:t>Werk → Expression → Manifestation → Exemplar</a:t>
+              <a:t>R: Programmiersprache und -umgebung von Statistikern für Statistiker, Open Source</a:t>
             </a:r>
           </a:p>
           <a:p>
             <a:pPr lvl="0"/>
             <a:r>
               <a:rPr/>
-              <a:t>Am Beispiel: </a:t>
-            </a:r>
-            <a:r>
-              <a:rPr i="1"/>
-              <a:t>The Green Mile</a:t>
-            </a:r>
-            <a:r>
-              <a:rPr/>
-              <a:t> (Werk) → deutsche Übersetzung (Expression) → Signet-Taschenbuch mit eigener ISBN (Manifestation) → das Buch im Regal (Exemplar)</a:t>
+              <a:t>RStudio: Integrierte Entwicklungsumgebung, kostenlos für viele Zwecke</a:t>
             </a:r>
           </a:p>
           <a:p>
             <a:pPr lvl="0"/>
             <a:r>
               <a:rPr/>
-              <a:t>Book-Crossing kennt </a:t>
-            </a:r>
-            <a:r>
-              <a:rPr b="1"/>
-              <a:t>nur ISBNs = Manifestationen</a:t>
-            </a:r>
-            <a:r>
-              <a:rPr/>
-              <a:t> — das Werk müssen wir per Data Mining rekonstruieren</a:t>
+              <a:t>Notebook im GitHub, kann mit der Software genutzt werden</a:t>
             </a:r>
           </a:p>
           <a:p>
             <a:pPr lvl="0"/>
             <a:r>
               <a:rPr/>
-              <a:t>Genau das macht gleich das Record Linkage</a:t>
+              <a:t>Was ist ein Notebook?</a:t>
             </a:r>
           </a:p>
         </p:txBody>
@@ -5941,7 +5637,7 @@
             </a:pPr>
             <a:r>
               <a:rPr/>
-              <a:t>Block 1: Konzepte klären</a:t>
+              <a:t>Konzepte klären</a:t>
             </a:r>
           </a:p>
         </p:txBody>
@@ -6924,7 +6620,7 @@
             </a:pPr>
             <a:r>
               <a:rPr/>
-              <a:t>Vom Supermarkt zu Book-Crossing</a:t>
+              <a:t>Vom Supermarkt zu BookCrossing</a:t>
             </a:r>
           </a:p>
         </p:txBody>
@@ -9122,14 +8818,14 @@
             <a:pPr lvl="0"/>
             <a:r>
               <a:rPr/>
-              <a:t>Die Begriffe sauber sortieren: KI, ML, Data Science, Data Mining</a:t>
+              <a:t>Die Begriffe sauber sortieren: KI, ML, LLMs, Data Science, Data Mining</a:t>
             </a:r>
           </a:p>
           <a:p>
             <a:pPr lvl="0"/>
             <a:r>
               <a:rPr/>
-              <a:t>Book-Crossing: vom rohen Datensatz zur Buchempfehlung</a:t>
+              <a:t>Data Mining mit dem BookCrossing-Datensatz</a:t>
             </a:r>
           </a:p>
         </p:txBody>
@@ -12190,7 +11886,7 @@
             <a:pPr lvl="0"/>
             <a:r>
               <a:rPr/>
-              <a:t>Alle folgenden Verfahren laufen auf demselben Book-Crossing-Datensatz</a:t>
+              <a:t>Alle folgenden Verfahren laufen auf demselben BookCrossing-Datensatz</a:t>
             </a:r>
           </a:p>
         </p:txBody>
@@ -12604,7 +12300,7 @@
                       </a:pPr>
                       <a:r>
                         <a:rPr/>
-                        <a:t>Begriffe, KI-Geschichte, CRISP-DM</a:t>
+                        <a:t>Begriffe &amp; Konzepte</a:t>
                       </a:r>
                     </a:p>
                   </a:txBody>
@@ -12662,7 +12358,7 @@
                       </a:pPr>
                       <a:r>
                         <a:rPr/>
-                        <a:t>Book-Crossing: Datenqualität &amp; Apriori</a:t>
+                        <a:t>Hands-on Data Mining</a:t>
                       </a:r>
                     </a:p>
                   </a:txBody>
@@ -15406,7 +15102,7 @@
             </a:pPr>
             <a:r>
               <a:rPr/>
-              <a:t>Clustering: Welche Lesertypen stecken in Book-Crossing?</a:t>
+              <a:t>Clustering: Welche Lesertypen stecken in BookCrossing?</a:t>
             </a:r>
           </a:p>
         </p:txBody>
@@ -15977,6 +15673,13 @@
               <a:t>tom@alby.de</a:t>
             </a:r>
           </a:p>
+          <a:p>
+            <a:pPr lvl="0"/>
+            <a:r>
+              <a:rPr/>
+              <a:t>Material auf GitHub (Link im Moodle)</a:t>
+            </a:r>
+          </a:p>
         </p:txBody>
       </p:sp>
     </p:spTree>
@@ -16067,6 +15770,55 @@
                                           <p:spTgt spid="3">
                                             <p:txEl>
                                               <p:pRg st="1" end="1"/>
+                                            </p:txEl>
+                                          </p:spTgt>
+                                        </p:tgtEl>
+                                        <p:attrNameLst>
+                                          <p:attrName>style.visibility</p:attrName>
+                                        </p:attrNameLst>
+                                      </p:cBhvr>
+                                      <p:to>
+                                        <p:strVal val="visible"/>
+                                      </p:to>
+                                    </p:set>
+                                  </p:childTnLst>
+                                </p:cTn>
+                              </p:par>
+                            </p:childTnLst>
+                          </p:cTn>
+                        </p:par>
+                      </p:childTnLst>
+                    </p:cTn>
+                  </p:par>
+                  <p:par>
+                    <p:cTn id="11" fill="hold">
+                      <p:stCondLst>
+                        <p:cond delay="indefinite"/>
+                      </p:stCondLst>
+                      <p:childTnLst>
+                        <p:par>
+                          <p:cTn id="12" fill="hold">
+                            <p:stCondLst>
+                              <p:cond delay="0"/>
+                            </p:stCondLst>
+                            <p:childTnLst>
+                              <p:par>
+                                <p:cTn id="13" presetID="1" presetClass="entr" presetSubtype="0" fill="hold" grpId="0" nodeType="clickEffect">
+                                  <p:stCondLst>
+                                    <p:cond delay="0"/>
+                                  </p:stCondLst>
+                                  <p:childTnLst>
+                                    <p:set>
+                                      <p:cBhvr>
+                                        <p:cTn id="14" dur="1" fill="hold">
+                                          <p:stCondLst>
+                                            <p:cond delay="0"/>
+                                          </p:stCondLst>
+                                        </p:cTn>
+                                        <p:tgtEl>
+                                          <p:spTgt spid="3">
+                                            <p:txEl>
+                                              <p:pRg st="2" end="2"/>
                                             </p:txEl>
                                           </p:spTgt>
                                         </p:tgtEl>
@@ -16468,7 +16220,7 @@
             <a:pPr lvl="0"/>
             <a:r>
               <a:rPr/>
-              <a:t>Unsere Frage an Book-Crossing: </a:t>
+              <a:t>Unsere Frage an BookCrossing: </a:t>
             </a:r>
             <a:r>
               <a:rPr b="1"/>
@@ -21222,55 +20974,66 @@
             <a:pPr lvl="0"/>
             <a:r>
               <a:rPr b="1"/>
-              <a:t>KI</a:t>
-            </a:r>
-            <a:r>
-              <a:rPr/>
-              <a:t>: Oberbegriff — Maschinen tun Dinge, die Intelligenz erfordern</a:t>
+              <a:t>KI:</a:t>
+            </a:r>
+            <a:r>
+              <a:rPr/>
+              <a:t> Oberbegriff — Maschinen verhalten sich intelligent.</a:t>
             </a:r>
           </a:p>
           <a:p>
             <a:pPr lvl="0"/>
             <a:r>
               <a:rPr b="1"/>
-              <a:t>Machine Learning</a:t>
-            </a:r>
-            <a:r>
-              <a:rPr/>
-              <a:t>: Teilmenge der KI — Lernen aus Daten statt fester Regeln</a:t>
+              <a:t>Machine Learning:</a:t>
+            </a:r>
+            <a:r>
+              <a:rPr/>
+              <a:t> Teilmenge der KI — Systeme lernen selbstständig aus Daten.</a:t>
             </a:r>
           </a:p>
           <a:p>
             <a:pPr lvl="0"/>
             <a:r>
               <a:rPr b="1"/>
-              <a:t>Data Mining</a:t>
-            </a:r>
-            <a:r>
-              <a:rPr/>
-              <a:t>: Mustersuche in (strukturierten) Daten — der Prozess</a:t>
+              <a:t>LLMs:</a:t>
+            </a:r>
+            <a:r>
+              <a:rPr/>
+              <a:t> Spezialform von ML — Modelle, die menschliche Sprache verstehen und generieren.</a:t>
             </a:r>
           </a:p>
           <a:p>
             <a:pPr lvl="0"/>
             <a:r>
               <a:rPr b="1"/>
-              <a:t>Text Mining</a:t>
-            </a:r>
-            <a:r>
-              <a:rPr/>
-              <a:t>: dasselbe für unstrukturierte Texte</a:t>
+              <a:t>Data Mining:</a:t>
+            </a:r>
+            <a:r>
+              <a:rPr/>
+              <a:t> Mustererkennung in strukturierten Daten.</a:t>
             </a:r>
           </a:p>
           <a:p>
             <a:pPr lvl="0"/>
             <a:r>
               <a:rPr b="1"/>
-              <a:t>Data Science</a:t>
-            </a:r>
-            <a:r>
-              <a:rPr/>
-              <a:t>: die Disziplin drumherum — inkl. Business Understanding, Kommunikation, Deployment</a:t>
+              <a:t>Text Mining:</a:t>
+            </a:r>
+            <a:r>
+              <a:rPr/>
+              <a:t> Mustererkennung in unstrukturierten Texten (heute oft durch LLMs gelöst).</a:t>
+            </a:r>
+          </a:p>
+          <a:p>
+            <a:pPr lvl="0"/>
+            <a:r>
+              <a:rPr b="1"/>
+              <a:t>Data Science:</a:t>
+            </a:r>
+            <a:r>
+              <a:rPr/>
+              <a:t> Die Disziplin drumherum — von der Analyse bis zum Business-Einsatz.</a:t>
             </a:r>
           </a:p>
         </p:txBody>
@@ -21510,6 +21273,55 @@
                                           <p:spTgt spid="3">
                                             <p:txEl>
                                               <p:pRg st="4" end="4"/>
+                                            </p:txEl>
+                                          </p:spTgt>
+                                        </p:tgtEl>
+                                        <p:attrNameLst>
+                                          <p:attrName>style.visibility</p:attrName>
+                                        </p:attrNameLst>
+                                      </p:cBhvr>
+                                      <p:to>
+                                        <p:strVal val="visible"/>
+                                      </p:to>
+                                    </p:set>
+                                  </p:childTnLst>
+                                </p:cTn>
+                              </p:par>
+                            </p:childTnLst>
+                          </p:cTn>
+                        </p:par>
+                      </p:childTnLst>
+                    </p:cTn>
+                  </p:par>
+                  <p:par>
+                    <p:cTn id="23" fill="hold">
+                      <p:stCondLst>
+                        <p:cond delay="indefinite"/>
+                      </p:stCondLst>
+                      <p:childTnLst>
+                        <p:par>
+                          <p:cTn id="24" fill="hold">
+                            <p:stCondLst>
+                              <p:cond delay="0"/>
+                            </p:stCondLst>
+                            <p:childTnLst>
+                              <p:par>
+                                <p:cTn id="25" presetID="1" presetClass="entr" presetSubtype="0" fill="hold" grpId="0" nodeType="clickEffect">
+                                  <p:stCondLst>
+                                    <p:cond delay="0"/>
+                                  </p:stCondLst>
+                                  <p:childTnLst>
+                                    <p:set>
+                                      <p:cBhvr>
+                                        <p:cTn id="26" dur="1" fill="hold">
+                                          <p:stCondLst>
+                                            <p:cond delay="0"/>
+                                          </p:stCondLst>
+                                        </p:cTn>
+                                        <p:tgtEl>
+                                          <p:spTgt spid="3">
+                                            <p:txEl>
+                                              <p:pRg st="5" end="5"/>
                                             </p:txEl>
                                           </p:spTgt>
                                         </p:tgtEl>
@@ -22556,7 +22368,7 @@
             </a:pPr>
             <a:r>
               <a:rPr/>
-              <a:t>Diskussion</a:t>
+              <a:t>Standortbestimmung</a:t>
             </a:r>
           </a:p>
         </p:txBody>
@@ -22579,21 +22391,21 @@
             <a:pPr lvl="0"/>
             <a:r>
               <a:rPr/>
-              <a:t>Mandl: Data Mining = strukturierte Daten, Text Mining = unstrukturierte Texte</a:t>
+              <a:t>Wo begegnen / nutzen Sie KI / Data Mining heute schon?</a:t>
             </a:r>
           </a:p>
           <a:p>
             <a:pPr lvl="0"/>
             <a:r>
-              <a:rPr b="1"/>
-              <a:t>Wo liegen Bibliothekskataloge auf diesem Spektrum?</a:t>
+              <a:rPr/>
+              <a:t>Wo würden Sie gerne KI / Data Mining nutzen?</a:t>
             </a:r>
           </a:p>
           <a:p>
             <a:pPr lvl="0"/>
             <a:r>
               <a:rPr/>
-              <a:t>Metadaten vs. Abstracts vs. Volltexte</a:t>
+              <a:t>Welche KI-Versprechen hören Bibliotheken aktuell von Anbietern?</a:t>
             </a:r>
           </a:p>
         </p:txBody>
@@ -22820,7 +22632,7 @@
             </a:pPr>
             <a:r>
               <a:rPr/>
-              <a:t>AI Springs &amp; Winters</a:t>
+              <a:t>Diskussion</a:t>
             </a:r>
           </a:p>
         </p:txBody>
@@ -22843,35 +22655,21 @@
             <a:pPr lvl="0"/>
             <a:r>
               <a:rPr/>
-              <a:t>1950er/60er: erster Frühling — Turing, Dartmouth, große Versprechen</a:t>
+              <a:t>Mandl: Data Mining = strukturierte Daten, Text Mining = unstrukturierte Texte</a:t>
             </a:r>
           </a:p>
           <a:p>
             <a:pPr lvl="0"/>
             <a:r>
               <a:rPr/>
-              <a:t>1970er: erster Winter — die Versprechen platzen</a:t>
+              <a:t>Wo liegen Bibliothekskataloge auf diesem Spektrum?</a:t>
             </a:r>
           </a:p>
           <a:p>
             <a:pPr lvl="0"/>
             <a:r>
               <a:rPr/>
-              <a:t>1980er: Expertensysteme — und der zweite Winter</a:t>
-            </a:r>
-          </a:p>
-          <a:p>
-            <a:pPr lvl="0"/>
-            <a:r>
-              <a:rPr/>
-              <a:t>Heute: dritter Frühling?</a:t>
-            </a:r>
-          </a:p>
-          <a:p>
-            <a:pPr lvl="0"/>
-            <a:r>
-              <a:rPr b="1"/>
-              <a:t>Woran würden Sie den nächsten Winter erkennen?</a:t>
+              <a:t>Metadaten vs. Abstracts vs. Volltexte</a:t>
             </a:r>
           </a:p>
         </p:txBody>
@@ -23013,104 +22811,6 @@
                                           <p:spTgt spid="3">
                                             <p:txEl>
                                               <p:pRg st="2" end="2"/>
-                                            </p:txEl>
-                                          </p:spTgt>
-                                        </p:tgtEl>
-                                        <p:attrNameLst>
-                                          <p:attrName>style.visibility</p:attrName>
-                                        </p:attrNameLst>
-                                      </p:cBhvr>
-                                      <p:to>
-                                        <p:strVal val="visible"/>
-                                      </p:to>
-                                    </p:set>
-                                  </p:childTnLst>
-                                </p:cTn>
-                              </p:par>
-                            </p:childTnLst>
-                          </p:cTn>
-                        </p:par>
-                      </p:childTnLst>
-                    </p:cTn>
-                  </p:par>
-                  <p:par>
-                    <p:cTn id="15" fill="hold">
-                      <p:stCondLst>
-                        <p:cond delay="indefinite"/>
-                      </p:stCondLst>
-                      <p:childTnLst>
-                        <p:par>
-                          <p:cTn id="16" fill="hold">
-                            <p:stCondLst>
-                              <p:cond delay="0"/>
-                            </p:stCondLst>
-                            <p:childTnLst>
-                              <p:par>
-                                <p:cTn id="17" presetID="1" presetClass="entr" presetSubtype="0" fill="hold" grpId="0" nodeType="clickEffect">
-                                  <p:stCondLst>
-                                    <p:cond delay="0"/>
-                                  </p:stCondLst>
-                                  <p:childTnLst>
-                                    <p:set>
-                                      <p:cBhvr>
-                                        <p:cTn id="18" dur="1" fill="hold">
-                                          <p:stCondLst>
-                                            <p:cond delay="0"/>
-                                          </p:stCondLst>
-                                        </p:cTn>
-                                        <p:tgtEl>
-                                          <p:spTgt spid="3">
-                                            <p:txEl>
-                                              <p:pRg st="3" end="3"/>
-                                            </p:txEl>
-                                          </p:spTgt>
-                                        </p:tgtEl>
-                                        <p:attrNameLst>
-                                          <p:attrName>style.visibility</p:attrName>
-                                        </p:attrNameLst>
-                                      </p:cBhvr>
-                                      <p:to>
-                                        <p:strVal val="visible"/>
-                                      </p:to>
-                                    </p:set>
-                                  </p:childTnLst>
-                                </p:cTn>
-                              </p:par>
-                            </p:childTnLst>
-                          </p:cTn>
-                        </p:par>
-                      </p:childTnLst>
-                    </p:cTn>
-                  </p:par>
-                  <p:par>
-                    <p:cTn id="19" fill="hold">
-                      <p:stCondLst>
-                        <p:cond delay="indefinite"/>
-                      </p:stCondLst>
-                      <p:childTnLst>
-                        <p:par>
-                          <p:cTn id="20" fill="hold">
-                            <p:stCondLst>
-                              <p:cond delay="0"/>
-                            </p:stCondLst>
-                            <p:childTnLst>
-                              <p:par>
-                                <p:cTn id="21" presetID="1" presetClass="entr" presetSubtype="0" fill="hold" grpId="0" nodeType="clickEffect">
-                                  <p:stCondLst>
-                                    <p:cond delay="0"/>
-                                  </p:stCondLst>
-                                  <p:childTnLst>
-                                    <p:set>
-                                      <p:cBhvr>
-                                        <p:cTn id="22" dur="1" fill="hold">
-                                          <p:stCondLst>
-                                            <p:cond delay="0"/>
-                                          </p:stCondLst>
-                                        </p:cTn>
-                                        <p:tgtEl>
-                                          <p:spTgt spid="3">
-                                            <p:txEl>
-                                              <p:pRg st="4" end="4"/>
                                             </p:txEl>
                                           </p:spTgt>
                                         </p:tgtEl>

</xml_diff>